<commit_message>
Use ABAKAS DIGITAL SOLUTIONS name; sign and stamp bid financial proposal
Replace 'Abakas Tech' with the registered company name in the bid
financial proposal and the construction proposal; add the authorized
signatory (Abdurehman Ahmed, General Manager), signature and company
stamp to the bidder's declaration.

Co-Authored-By: Claude Opus 5.5 <noreply@anthropic.com>
Claude-Session: https://claude.ai/code/session_01JN1xXW5sGZrcbeUUaddYi7
</commit_message>
<xml_diff>
--- a/docs/proposals/O-YES_EMIS_Financial_Proposal_Bid.pptx
+++ b/docs/proposals/O-YES_EMIS_Financial_Proposal_Bid.pptx
@@ -1833,7 +1833,7 @@
                 <a:ea typeface="Calibri" pitchFamily="34" charset="-122"/>
                 <a:cs typeface="Calibri" pitchFamily="34" charset="-120"/>
               </a:rPr>
-              <a:t>Abakas Tech</a:t>
+              <a:t>ABAKAS DIGITAL SOLUTIONS</a:t>
             </a:r>
             <a:endParaRPr lang="en-US" sz="1350" dirty="0"/>
           </a:p>
@@ -23815,8 +23815,8 @@
         </p:nvSpPr>
         <p:spPr>
           <a:xfrm>
-            <a:off x="548640" y="2971800"/>
-            <a:ext cx="5303520" cy="274320"/>
+            <a:off x="548640" y="2743200"/>
+            <a:ext cx="5486400" cy="256032"/>
           </a:xfrm>
           <a:prstGeom prst="rect">
             <a:avLst/>
@@ -23854,8 +23854,8 @@
         </p:nvSpPr>
         <p:spPr>
           <a:xfrm>
-            <a:off x="548640" y="3291840"/>
-            <a:ext cx="5303520" cy="365760"/>
+            <a:off x="548640" y="3035808"/>
+            <a:ext cx="5486400" cy="347472"/>
           </a:xfrm>
           <a:prstGeom prst="rect">
             <a:avLst/>
@@ -23879,7 +23879,7 @@
                 <a:ea typeface="Calibri" pitchFamily="34" charset="-122"/>
                 <a:cs typeface="Calibri" pitchFamily="34" charset="-120"/>
               </a:rPr>
-              <a:t>Abakas Tech</a:t>
+              <a:t>ABAKAS DIGITAL SOLUTIONS</a:t>
             </a:r>
             <a:endParaRPr lang="en-US" sz="1500" dirty="0"/>
           </a:p>
@@ -23893,8 +23893,8 @@
         </p:nvSpPr>
         <p:spPr>
           <a:xfrm>
-            <a:off x="548640" y="3703320"/>
-            <a:ext cx="5303520" cy="0"/>
+            <a:off x="548640" y="3438144"/>
+            <a:ext cx="5486400" cy="0"/>
           </a:xfrm>
           <a:prstGeom prst="line">
             <a:avLst/>
@@ -23916,8 +23916,8 @@
         </p:nvSpPr>
         <p:spPr>
           <a:xfrm>
-            <a:off x="6172200" y="2971800"/>
-            <a:ext cx="5303520" cy="274320"/>
+            <a:off x="548640" y="3639312"/>
+            <a:ext cx="5486400" cy="256032"/>
           </a:xfrm>
           <a:prstGeom prst="rect">
             <a:avLst/>
@@ -23949,14 +23949,53 @@
       </p:sp>
       <p:sp>
         <p:nvSpPr>
-          <p:cNvPr id="11" name="Shape 9"/>
+          <p:cNvPr id="11" name="Text 9"/>
+          <p:cNvSpPr txBox="1"/>
+          <p:nvPr/>
+        </p:nvSpPr>
+        <p:spPr>
+          <a:xfrm>
+            <a:off x="548640" y="3931920"/>
+            <a:ext cx="5486400" cy="347472"/>
+          </a:xfrm>
+          <a:prstGeom prst="rect">
+            <a:avLst/>
+          </a:prstGeom>
+          <a:noFill/>
+          <a:ln/>
+        </p:spPr>
+        <p:txBody>
+          <a:bodyPr wrap="square" lIns="0" tIns="0" rIns="0" bIns="0" rtlCol="0" anchor="ctr"/>
+          <a:lstStyle/>
+          <a:p>
+            <a:pPr indent="0" marL="0">
+              <a:buNone/>
+            </a:pPr>
+            <a:r>
+              <a:rPr lang="en-US" sz="1500" b="1" dirty="0">
+                <a:solidFill>
+                  <a:srgbClr val="0B3033"/>
+                </a:solidFill>
+                <a:latin typeface="Calibri" pitchFamily="34" charset="0"/>
+                <a:ea typeface="Calibri" pitchFamily="34" charset="-122"/>
+                <a:cs typeface="Calibri" pitchFamily="34" charset="-120"/>
+              </a:rPr>
+              <a:t>Abdurehman Ahmed</a:t>
+            </a:r>
+            <a:endParaRPr lang="en-US" sz="1500" dirty="0"/>
+          </a:p>
+        </p:txBody>
+      </p:sp>
+      <p:sp>
+        <p:nvSpPr>
+          <p:cNvPr id="12" name="Shape 10"/>
           <p:cNvSpPr/>
           <p:nvPr/>
         </p:nvSpPr>
         <p:spPr>
           <a:xfrm>
-            <a:off x="6172200" y="3703320"/>
-            <a:ext cx="5303520" cy="0"/>
+            <a:off x="548640" y="4334256"/>
+            <a:ext cx="5486400" cy="0"/>
           </a:xfrm>
           <a:prstGeom prst="line">
             <a:avLst/>
@@ -23972,14 +24011,14 @@
       </p:sp>
       <p:sp>
         <p:nvSpPr>
-          <p:cNvPr id="12" name="Text 10"/>
+          <p:cNvPr id="13" name="Text 11"/>
           <p:cNvSpPr txBox="1"/>
           <p:nvPr/>
         </p:nvSpPr>
         <p:spPr>
           <a:xfrm>
-            <a:off x="548640" y="4023360"/>
-            <a:ext cx="5303520" cy="274320"/>
+            <a:off x="548640" y="4535424"/>
+            <a:ext cx="5486400" cy="256032"/>
           </a:xfrm>
           <a:prstGeom prst="rect">
             <a:avLst/>
@@ -24011,37 +24050,14 @@
       </p:sp>
       <p:sp>
         <p:nvSpPr>
-          <p:cNvPr id="13" name="Shape 11"/>
-          <p:cNvSpPr/>
-          <p:nvPr/>
-        </p:nvSpPr>
-        <p:spPr>
-          <a:xfrm>
-            <a:off x="548640" y="4754880"/>
-            <a:ext cx="5303520" cy="0"/>
-          </a:xfrm>
-          <a:prstGeom prst="line">
-            <a:avLst/>
-          </a:prstGeom>
-          <a:noFill/>
-          <a:ln w="12700">
-            <a:solidFill>
-              <a:srgbClr val="8A9A9B"/>
-            </a:solidFill>
-            <a:prstDash val="solid"/>
-          </a:ln>
-        </p:spPr>
-      </p:sp>
-      <p:sp>
-        <p:nvSpPr>
           <p:cNvPr id="14" name="Text 12"/>
           <p:cNvSpPr txBox="1"/>
           <p:nvPr/>
         </p:nvSpPr>
         <p:spPr>
           <a:xfrm>
-            <a:off x="6172200" y="4023360"/>
-            <a:ext cx="5303520" cy="274320"/>
+            <a:off x="548640" y="4828032"/>
+            <a:ext cx="5486400" cy="347472"/>
           </a:xfrm>
           <a:prstGeom prst="rect">
             <a:avLst/>
@@ -24057,17 +24073,17 @@
               <a:buNone/>
             </a:pPr>
             <a:r>
-              <a:rPr lang="en-US" sz="1200" b="1" dirty="0">
+              <a:rPr lang="en-US" sz="1500" b="1" dirty="0">
                 <a:solidFill>
-                  <a:srgbClr val="5E6E70"/>
+                  <a:srgbClr val="0B3033"/>
                 </a:solidFill>
                 <a:latin typeface="Calibri" pitchFamily="34" charset="0"/>
                 <a:ea typeface="Calibri" pitchFamily="34" charset="-122"/>
                 <a:cs typeface="Calibri" pitchFamily="34" charset="-120"/>
               </a:rPr>
-              <a:t>Signature</a:t>
+              <a:t>General Manager</a:t>
             </a:r>
-            <a:endParaRPr lang="en-US" sz="1200" dirty="0"/>
+            <a:endParaRPr lang="en-US" sz="1500" dirty="0"/>
           </a:p>
         </p:txBody>
       </p:sp>
@@ -24079,8 +24095,8 @@
         </p:nvSpPr>
         <p:spPr>
           <a:xfrm>
-            <a:off x="6172200" y="4754880"/>
-            <a:ext cx="5303520" cy="0"/>
+            <a:off x="548640" y="5230368"/>
+            <a:ext cx="5486400" cy="0"/>
           </a:xfrm>
           <a:prstGeom prst="line">
             <a:avLst/>
@@ -24102,8 +24118,8 @@
         </p:nvSpPr>
         <p:spPr>
           <a:xfrm>
-            <a:off x="548640" y="5074920"/>
-            <a:ext cx="5303520" cy="274320"/>
+            <a:off x="548640" y="5431536"/>
+            <a:ext cx="5486400" cy="256032"/>
           </a:xfrm>
           <a:prstGeom prst="rect">
             <a:avLst/>
@@ -24141,8 +24157,8 @@
         </p:nvSpPr>
         <p:spPr>
           <a:xfrm>
-            <a:off x="548640" y="5806440"/>
-            <a:ext cx="5303520" cy="0"/>
+            <a:off x="548640" y="6126480"/>
+            <a:ext cx="5486400" cy="0"/>
           </a:xfrm>
           <a:prstGeom prst="line">
             <a:avLst/>
@@ -24164,8 +24180,94 @@
         </p:nvSpPr>
         <p:spPr>
           <a:xfrm>
-            <a:off x="6172200" y="5074920"/>
-            <a:ext cx="5303520" cy="274320"/>
+            <a:off x="6675120" y="2743200"/>
+            <a:ext cx="2194560" cy="256032"/>
+          </a:xfrm>
+          <a:prstGeom prst="rect">
+            <a:avLst/>
+          </a:prstGeom>
+          <a:noFill/>
+          <a:ln/>
+        </p:spPr>
+        <p:txBody>
+          <a:bodyPr wrap="square" lIns="0" tIns="0" rIns="0" bIns="0" rtlCol="0" anchor="ctr"/>
+          <a:lstStyle/>
+          <a:p>
+            <a:pPr indent="0" marL="0">
+              <a:buNone/>
+            </a:pPr>
+            <a:r>
+              <a:rPr lang="en-US" sz="1200" b="1" dirty="0">
+                <a:solidFill>
+                  <a:srgbClr val="5E6E70"/>
+                </a:solidFill>
+                <a:latin typeface="Calibri" pitchFamily="34" charset="0"/>
+                <a:ea typeface="Calibri" pitchFamily="34" charset="-122"/>
+                <a:cs typeface="Calibri" pitchFamily="34" charset="-120"/>
+              </a:rPr>
+              <a:t>Signature</a:t>
+            </a:r>
+            <a:endParaRPr lang="en-US" sz="1200" dirty="0"/>
+          </a:p>
+        </p:txBody>
+      </p:sp>
+      <p:pic>
+        <p:nvPicPr>
+          <p:cNvPr id="19" name="Image 0" descr="preencoded.png">    </p:cNvPr>
+          <p:cNvPicPr>
+            <a:picLocks noChangeAspect="1"/>
+          </p:cNvPicPr>
+          <p:nvPr/>
+        </p:nvPicPr>
+        <p:blipFill>
+          <a:blip r:embed="rId1"/>
+          <a:stretch>
+            <a:fillRect/>
+          </a:stretch>
+        </p:blipFill>
+        <p:spPr>
+          <a:xfrm>
+            <a:off x="7132320" y="3017520"/>
+            <a:ext cx="603832" cy="1463040"/>
+          </a:xfrm>
+          <a:prstGeom prst="rect">
+            <a:avLst/>
+          </a:prstGeom>
+        </p:spPr>
+      </p:pic>
+      <p:sp>
+        <p:nvSpPr>
+          <p:cNvPr id="20" name="Shape 17"/>
+          <p:cNvSpPr/>
+          <p:nvPr/>
+        </p:nvSpPr>
+        <p:spPr>
+          <a:xfrm>
+            <a:off x="6675120" y="4526280"/>
+            <a:ext cx="2194560" cy="0"/>
+          </a:xfrm>
+          <a:prstGeom prst="line">
+            <a:avLst/>
+          </a:prstGeom>
+          <a:noFill/>
+          <a:ln w="12700">
+            <a:solidFill>
+              <a:srgbClr val="8A9A9B"/>
+            </a:solidFill>
+            <a:prstDash val="solid"/>
+          </a:ln>
+        </p:spPr>
+      </p:sp>
+      <p:sp>
+        <p:nvSpPr>
+          <p:cNvPr id="21" name="Text 18"/>
+          <p:cNvSpPr txBox="1"/>
+          <p:nvPr/>
+        </p:nvSpPr>
+        <p:spPr>
+          <a:xfrm>
+            <a:off x="9189720" y="2743200"/>
+            <a:ext cx="2377440" cy="256032"/>
           </a:xfrm>
           <a:prstGeom prst="rect">
             <a:avLst/>
@@ -24195,29 +24297,30 @@
           </a:p>
         </p:txBody>
       </p:sp>
-      <p:sp>
-        <p:nvSpPr>
-          <p:cNvPr id="19" name="Shape 17"/>
-          <p:cNvSpPr/>
+      <p:pic>
+        <p:nvPicPr>
+          <p:cNvPr id="22" name="Image 1" descr="preencoded.png">    </p:cNvPr>
+          <p:cNvPicPr>
+            <a:picLocks noChangeAspect="1"/>
+          </p:cNvPicPr>
           <p:nvPr/>
-        </p:nvSpPr>
+        </p:nvPicPr>
+        <p:blipFill>
+          <a:blip r:embed="rId2"/>
+          <a:stretch>
+            <a:fillRect/>
+          </a:stretch>
+        </p:blipFill>
         <p:spPr>
           <a:xfrm>
-            <a:off x="6172200" y="5806440"/>
-            <a:ext cx="5303520" cy="0"/>
+            <a:off x="9189720" y="3063240"/>
+            <a:ext cx="2331720" cy="2264209"/>
           </a:xfrm>
-          <a:prstGeom prst="line">
+          <a:prstGeom prst="rect">
             <a:avLst/>
           </a:prstGeom>
-          <a:noFill/>
-          <a:ln w="12700">
-            <a:solidFill>
-              <a:srgbClr val="8A9A9B"/>
-            </a:solidFill>
-            <a:prstDash val="solid"/>
-          </a:ln>
         </p:spPr>
-      </p:sp>
+      </p:pic>
     </p:spTree>
   </p:cSld>
   <p:clrMapOvr>

</xml_diff>

<commit_message>
Fix signature orientation, complete stamp and add date on bid declaration
Co-Authored-By: Claude Opus 5.5 <noreply@anthropic.com>
Claude-Session: https://claude.ai/code/session_01JN1xXW5sGZrcbeUUaddYi7
</commit_message>
<xml_diff>
--- a/docs/proposals/O-YES_EMIS_Financial_Proposal_Bid.pptx
+++ b/docs/proposals/O-YES_EMIS_Financial_Proposal_Bid.pptx
@@ -24151,7 +24151,46 @@
       </p:sp>
       <p:sp>
         <p:nvSpPr>
-          <p:cNvPr id="17" name="Shape 15"/>
+          <p:cNvPr id="17" name="Text 15"/>
+          <p:cNvSpPr txBox="1"/>
+          <p:nvPr/>
+        </p:nvSpPr>
+        <p:spPr>
+          <a:xfrm>
+            <a:off x="548640" y="5724144"/>
+            <a:ext cx="5486400" cy="347472"/>
+          </a:xfrm>
+          <a:prstGeom prst="rect">
+            <a:avLst/>
+          </a:prstGeom>
+          <a:noFill/>
+          <a:ln/>
+        </p:spPr>
+        <p:txBody>
+          <a:bodyPr wrap="square" lIns="0" tIns="0" rIns="0" bIns="0" rtlCol="0" anchor="ctr"/>
+          <a:lstStyle/>
+          <a:p>
+            <a:pPr indent="0" marL="0">
+              <a:buNone/>
+            </a:pPr>
+            <a:r>
+              <a:rPr lang="en-US" sz="1500" b="1" dirty="0">
+                <a:solidFill>
+                  <a:srgbClr val="0B3033"/>
+                </a:solidFill>
+                <a:latin typeface="Calibri" pitchFamily="34" charset="0"/>
+                <a:ea typeface="Calibri" pitchFamily="34" charset="-122"/>
+                <a:cs typeface="Calibri" pitchFamily="34" charset="-120"/>
+              </a:rPr>
+              <a:t>October 7, 2026</a:t>
+            </a:r>
+            <a:endParaRPr lang="en-US" sz="1500" dirty="0"/>
+          </a:p>
+        </p:txBody>
+      </p:sp>
+      <p:sp>
+        <p:nvSpPr>
+          <p:cNvPr id="18" name="Shape 16"/>
           <p:cNvSpPr/>
           <p:nvPr/>
         </p:nvSpPr>
@@ -24174,14 +24213,14 @@
       </p:sp>
       <p:sp>
         <p:nvSpPr>
-          <p:cNvPr id="18" name="Text 16"/>
+          <p:cNvPr id="19" name="Text 17"/>
           <p:cNvSpPr txBox="1"/>
           <p:nvPr/>
         </p:nvSpPr>
         <p:spPr>
           <a:xfrm>
             <a:off x="6675120" y="2743200"/>
-            <a:ext cx="2194560" cy="256032"/>
+            <a:ext cx="2377440" cy="256032"/>
           </a:xfrm>
           <a:prstGeom prst="rect">
             <a:avLst/>
@@ -24213,7 +24252,7 @@
       </p:sp>
       <p:pic>
         <p:nvPicPr>
-          <p:cNvPr id="19" name="Image 0" descr="preencoded.png">    </p:cNvPr>
+          <p:cNvPr id="20" name="Image 0" descr="preencoded.png">    </p:cNvPr>
           <p:cNvPicPr>
             <a:picLocks noChangeAspect="1"/>
           </p:cNvPicPr>
@@ -24227,8 +24266,8 @@
         </p:blipFill>
         <p:spPr>
           <a:xfrm>
-            <a:off x="7132320" y="3017520"/>
-            <a:ext cx="603832" cy="1463040"/>
+            <a:off x="6766560" y="3429000"/>
+            <a:ext cx="2194560" cy="905748"/>
           </a:xfrm>
           <a:prstGeom prst="rect">
             <a:avLst/>
@@ -24237,14 +24276,14 @@
       </p:pic>
       <p:sp>
         <p:nvSpPr>
-          <p:cNvPr id="20" name="Shape 17"/>
+          <p:cNvPr id="21" name="Shape 18"/>
           <p:cNvSpPr/>
           <p:nvPr/>
         </p:nvSpPr>
         <p:spPr>
           <a:xfrm>
-            <a:off x="6675120" y="4526280"/>
-            <a:ext cx="2194560" cy="0"/>
+            <a:off x="6675120" y="4352544"/>
+            <a:ext cx="2377440" cy="0"/>
           </a:xfrm>
           <a:prstGeom prst="line">
             <a:avLst/>
@@ -24260,13 +24299,13 @@
       </p:sp>
       <p:sp>
         <p:nvSpPr>
-          <p:cNvPr id="21" name="Text 18"/>
+          <p:cNvPr id="22" name="Text 19"/>
           <p:cNvSpPr txBox="1"/>
           <p:nvPr/>
         </p:nvSpPr>
         <p:spPr>
           <a:xfrm>
-            <a:off x="9189720" y="2743200"/>
+            <a:off x="9281160" y="2743200"/>
             <a:ext cx="2377440" cy="256032"/>
           </a:xfrm>
           <a:prstGeom prst="rect">
@@ -24299,7 +24338,7 @@
       </p:sp>
       <p:pic>
         <p:nvPicPr>
-          <p:cNvPr id="22" name="Image 1" descr="preencoded.png">    </p:cNvPr>
+          <p:cNvPr id="23" name="Image 1" descr="preencoded.png">    </p:cNvPr>
           <p:cNvPicPr>
             <a:picLocks noChangeAspect="1"/>
           </p:cNvPicPr>
@@ -24313,8 +24352,8 @@
         </p:blipFill>
         <p:spPr>
           <a:xfrm>
-            <a:off x="9189720" y="3063240"/>
-            <a:ext cx="2331720" cy="2264209"/>
+            <a:off x="9281160" y="3063240"/>
+            <a:ext cx="2286000" cy="2232601"/>
           </a:xfrm>
           <a:prstGeom prst="rect">
             <a:avLst/>

</xml_diff>